<commit_message>
Updated lecture 10 slides
</commit_message>
<xml_diff>
--- a/lectures/10.Light.Sources.pptx
+++ b/lectures/10.Light.Sources.pptx
@@ -17259,7 +17259,7 @@
                 </a:solidFill>
                 <a:latin typeface="Garamond" panose="02020404030301010803" pitchFamily="18" charset="0"/>
               </a:rPr>
-              <a:t>This year</a:t>
+              <a:t>2025</a:t>
             </a:r>
           </a:p>
         </p:txBody>
@@ -18244,7 +18244,7 @@
                 <a:ea typeface="Helvetica Neue" panose="02000503000000020004" pitchFamily="2" charset="0"/>
                 <a:cs typeface="Helvetica Neue" panose="02000503000000020004" pitchFamily="2" charset="0"/>
               </a:rPr>
-              <a:t>10e+12 possibilities</a:t>
+              <a:t>10^12 possibilities</a:t>
             </a:r>
           </a:p>
         </p:txBody>
@@ -18481,7 +18481,7 @@
                   <a:ea typeface="Helvetica Neue" panose="02000503000000020004" pitchFamily="2" charset="0"/>
                   <a:cs typeface="Helvetica Neue" panose="02000503000000020004" pitchFamily="2" charset="0"/>
                 </a:rPr>
-                <a:t>Up to 114 alphanumeric characters 14^44 = 9.2e+94 possibilities </a:t>
+                <a:t>Up to 114 alphanumeric characters 45^144 = 10^187 possibilities </a:t>
               </a:r>
             </a:p>
           </p:txBody>

</xml_diff>